<commit_message>
Updated the final presentation
I revised the final presentation to add an "Application Functions" slide.
</commit_message>
<xml_diff>
--- a/src/main/resources/presentation/FinalPresentation.pptx
+++ b/src/main/resources/presentation/FinalPresentation.pptx
@@ -8,7 +8,8 @@
     <p:sldId id="256" r:id="rId2"/>
     <p:sldId id="257" r:id="rId3"/>
     <p:sldId id="258" r:id="rId4"/>
-    <p:sldId id="259" r:id="rId5"/>
+    <p:sldId id="260" r:id="rId5"/>
+    <p:sldId id="259" r:id="rId6"/>
   </p:sldIdLst>
   <p:sldSz cx="12192000" cy="6858000"/>
   <p:notesSz cx="6858000" cy="9144000"/>
@@ -107,7 +108,142 @@
       </a:defRPr>
     </a:lvl9pPr>
   </p:defaultTextStyle>
+  <p:extLst>
+    <p:ext uri="{EFAFB233-063F-42B5-8137-9DF3F51BA10A}">
+      <p15:sldGuideLst xmlns:p15="http://schemas.microsoft.com/office/powerpoint/2012/main"/>
+    </p:ext>
+  </p:extLst>
 </p:presentation>
+</file>
+
+<file path=ppt/revisionInfo.xml><?xml version="1.0" encoding="utf-8"?>
+<p1510:revInfo xmlns:a="http://schemas.openxmlformats.org/drawingml/2006/main" xmlns:r="http://schemas.openxmlformats.org/officeDocument/2006/relationships" xmlns:p1510="http://schemas.microsoft.com/office/powerpoint/2015/10/main">
+  <p1510:revLst>
+    <p1510:client id="{7A89C5F4-64F2-4DBB-A2A9-500E087105C4}" v="3" dt="2026-04-27T00:35:30.900"/>
+  </p1510:revLst>
+</p1510:revInfo>
+</file>
+
+<file path=ppt/changesInfos/changesInfo1.xml><?xml version="1.0" encoding="utf-8"?>
+<pc:chgInfo xmlns:a="http://schemas.openxmlformats.org/drawingml/2006/main" xmlns:r="http://schemas.openxmlformats.org/officeDocument/2006/relationships" xmlns:ac="http://schemas.microsoft.com/office/drawing/2013/main/command" xmlns:pc="http://schemas.microsoft.com/office/powerpoint/2013/main/command">
+  <pc:docChgLst>
+    <pc:chgData name="Xander Fry" userId="6b0bdad8c40015c8" providerId="LiveId" clId="{A71836FE-40E8-4C5B-AE2A-EF81233CB0BA}"/>
+    <pc:docChg chg="undo custSel addSld delSld modSld sldOrd">
+      <pc:chgData name="Xander Fry" userId="6b0bdad8c40015c8" providerId="LiveId" clId="{A71836FE-40E8-4C5B-AE2A-EF81233CB0BA}" dt="2026-04-27T00:35:35.429" v="670" actId="26606"/>
+      <pc:docMkLst>
+        <pc:docMk/>
+      </pc:docMkLst>
+      <pc:sldChg chg="addSp delSp add del ord setBg delDesignElem">
+        <pc:chgData name="Xander Fry" userId="6b0bdad8c40015c8" providerId="LiveId" clId="{A71836FE-40E8-4C5B-AE2A-EF81233CB0BA}" dt="2026-04-27T00:17:55.327" v="9"/>
+        <pc:sldMkLst>
+          <pc:docMk/>
+          <pc:sldMk cId="1045348694" sldId="260"/>
+        </pc:sldMkLst>
+        <pc:spChg chg="add del">
+          <ac:chgData name="Xander Fry" userId="6b0bdad8c40015c8" providerId="LiveId" clId="{A71836FE-40E8-4C5B-AE2A-EF81233CB0BA}" dt="2026-04-27T00:17:55.327" v="9"/>
+          <ac:spMkLst>
+            <pc:docMk/>
+            <pc:sldMk cId="1045348694" sldId="260"/>
+            <ac:spMk id="10" creationId="{8DC9A6AB-1CA7-A5A4-C6CA-111675E64B1F}"/>
+          </ac:spMkLst>
+        </pc:spChg>
+        <pc:spChg chg="add del">
+          <ac:chgData name="Xander Fry" userId="6b0bdad8c40015c8" providerId="LiveId" clId="{A71836FE-40E8-4C5B-AE2A-EF81233CB0BA}" dt="2026-04-27T00:17:55.327" v="9"/>
+          <ac:spMkLst>
+            <pc:docMk/>
+            <pc:sldMk cId="1045348694" sldId="260"/>
+            <ac:spMk id="12" creationId="{1B390E73-7085-0464-A5B9-FE8768672397}"/>
+          </ac:spMkLst>
+        </pc:spChg>
+      </pc:sldChg>
+      <pc:sldChg chg="new del">
+        <pc:chgData name="Xander Fry" userId="6b0bdad8c40015c8" providerId="LiveId" clId="{A71836FE-40E8-4C5B-AE2A-EF81233CB0BA}" dt="2026-04-27T00:17:38.086" v="1" actId="47"/>
+        <pc:sldMkLst>
+          <pc:docMk/>
+          <pc:sldMk cId="2773564795" sldId="260"/>
+        </pc:sldMkLst>
+      </pc:sldChg>
+      <pc:sldChg chg="addSp delSp modSp add mod ord">
+        <pc:chgData name="Xander Fry" userId="6b0bdad8c40015c8" providerId="LiveId" clId="{A71836FE-40E8-4C5B-AE2A-EF81233CB0BA}" dt="2026-04-27T00:35:35.429" v="670" actId="26606"/>
+        <pc:sldMkLst>
+          <pc:docMk/>
+          <pc:sldMk cId="3285580046" sldId="260"/>
+        </pc:sldMkLst>
+        <pc:spChg chg="mod">
+          <ac:chgData name="Xander Fry" userId="6b0bdad8c40015c8" providerId="LiveId" clId="{A71836FE-40E8-4C5B-AE2A-EF81233CB0BA}" dt="2026-04-27T00:35:35.429" v="670" actId="26606"/>
+          <ac:spMkLst>
+            <pc:docMk/>
+            <pc:sldMk cId="3285580046" sldId="260"/>
+            <ac:spMk id="2" creationId="{4B3CA238-DF55-4DA3-B1DE-FF704AA9078B}"/>
+          </ac:spMkLst>
+        </pc:spChg>
+        <pc:spChg chg="mod">
+          <ac:chgData name="Xander Fry" userId="6b0bdad8c40015c8" providerId="LiveId" clId="{A71836FE-40E8-4C5B-AE2A-EF81233CB0BA}" dt="2026-04-27T00:35:35.429" v="670" actId="26606"/>
+          <ac:spMkLst>
+            <pc:docMk/>
+            <pc:sldMk cId="3285580046" sldId="260"/>
+            <ac:spMk id="3" creationId="{EBA7333B-4D4C-9EFF-3C3B-48FAE12EE2A3}"/>
+          </ac:spMkLst>
+        </pc:spChg>
+        <pc:spChg chg="del">
+          <ac:chgData name="Xander Fry" userId="6b0bdad8c40015c8" providerId="LiveId" clId="{A71836FE-40E8-4C5B-AE2A-EF81233CB0BA}" dt="2026-04-27T00:35:35.429" v="670" actId="26606"/>
+          <ac:spMkLst>
+            <pc:docMk/>
+            <pc:sldMk cId="3285580046" sldId="260"/>
+            <ac:spMk id="10" creationId="{023967FA-8238-3C07-124A-333EA6472DDD}"/>
+          </ac:spMkLst>
+        </pc:spChg>
+        <pc:spChg chg="del">
+          <ac:chgData name="Xander Fry" userId="6b0bdad8c40015c8" providerId="LiveId" clId="{A71836FE-40E8-4C5B-AE2A-EF81233CB0BA}" dt="2026-04-27T00:35:35.429" v="670" actId="26606"/>
+          <ac:spMkLst>
+            <pc:docMk/>
+            <pc:sldMk cId="3285580046" sldId="260"/>
+            <ac:spMk id="12" creationId="{F9BD64ED-B8D3-7BC6-5C74-F87B8F642389}"/>
+          </ac:spMkLst>
+        </pc:spChg>
+        <pc:spChg chg="add">
+          <ac:chgData name="Xander Fry" userId="6b0bdad8c40015c8" providerId="LiveId" clId="{A71836FE-40E8-4C5B-AE2A-EF81233CB0BA}" dt="2026-04-27T00:35:35.429" v="670" actId="26606"/>
+          <ac:spMkLst>
+            <pc:docMk/>
+            <pc:sldMk cId="3285580046" sldId="260"/>
+            <ac:spMk id="17" creationId="{1660E788-AFA9-4A1B-9991-6AA74632A15B}"/>
+          </ac:spMkLst>
+        </pc:spChg>
+        <pc:spChg chg="add">
+          <ac:chgData name="Xander Fry" userId="6b0bdad8c40015c8" providerId="LiveId" clId="{A71836FE-40E8-4C5B-AE2A-EF81233CB0BA}" dt="2026-04-27T00:35:35.429" v="670" actId="26606"/>
+          <ac:spMkLst>
+            <pc:docMk/>
+            <pc:sldMk cId="3285580046" sldId="260"/>
+            <ac:spMk id="19" creationId="{867D4867-5BA7-4462-B2F6-A23F4A622AA7}"/>
+          </ac:spMkLst>
+        </pc:spChg>
+        <pc:picChg chg="add mod">
+          <ac:chgData name="Xander Fry" userId="6b0bdad8c40015c8" providerId="LiveId" clId="{A71836FE-40E8-4C5B-AE2A-EF81233CB0BA}" dt="2026-04-27T00:35:35.429" v="670" actId="26606"/>
+          <ac:picMkLst>
+            <pc:docMk/>
+            <pc:sldMk cId="3285580046" sldId="260"/>
+            <ac:picMk id="5" creationId="{839CD98F-A31F-E243-FA84-1F33A652D132}"/>
+          </ac:picMkLst>
+        </pc:picChg>
+        <pc:picChg chg="del">
+          <ac:chgData name="Xander Fry" userId="6b0bdad8c40015c8" providerId="LiveId" clId="{A71836FE-40E8-4C5B-AE2A-EF81233CB0BA}" dt="2026-04-27T00:33:47.209" v="668" actId="478"/>
+          <ac:picMkLst>
+            <pc:docMk/>
+            <pc:sldMk cId="3285580046" sldId="260"/>
+            <ac:picMk id="7" creationId="{A5E427BD-EE81-6CDB-469A-1EE42D1BFE1A}"/>
+          </ac:picMkLst>
+        </pc:picChg>
+      </pc:sldChg>
+      <pc:sldChg chg="new del">
+        <pc:chgData name="Xander Fry" userId="6b0bdad8c40015c8" providerId="LiveId" clId="{A71836FE-40E8-4C5B-AE2A-EF81233CB0BA}" dt="2026-04-27T00:17:47.877" v="3" actId="47"/>
+        <pc:sldMkLst>
+          <pc:docMk/>
+          <pc:sldMk cId="3392809346" sldId="260"/>
+        </pc:sldMkLst>
+      </pc:sldChg>
+    </pc:docChg>
+  </pc:docChgLst>
+</pc:chgInfo>
 </file>
 
 <file path=ppt/slideLayouts/slideLayout1.xml><?xml version="1.0" encoding="utf-8"?>
@@ -273,7 +409,7 @@
           <a:p>
             <a:fld id="{1160EA64-D806-43AC-9DF2-F8C432F32B4C}" type="datetimeFigureOut">
               <a:rPr lang="en-US" dirty="0"/>
-              <a:t>4/25/26</a:t>
+              <a:t>4/26/2026</a:t>
             </a:fld>
             <a:endParaRPr lang="en-US" dirty="0"/>
           </a:p>
@@ -439,7 +575,7 @@
           <a:p>
             <a:fld id="{E9F9C37B-1D36-470B-8223-D6C91242EC14}" type="datetimeFigureOut">
               <a:rPr lang="en-US" dirty="0"/>
-              <a:t>4/25/26</a:t>
+              <a:t>4/26/2026</a:t>
             </a:fld>
             <a:endParaRPr lang="en-US" dirty="0"/>
           </a:p>
@@ -614,7 +750,7 @@
           <a:p>
             <a:fld id="{67C6F52A-A82B-47A2-A83A-8C4C91F2D59F}" type="datetimeFigureOut">
               <a:rPr lang="en-US" dirty="0"/>
-              <a:t>4/25/26</a:t>
+              <a:t>4/26/2026</a:t>
             </a:fld>
             <a:endParaRPr lang="en-US" dirty="0"/>
           </a:p>
@@ -779,7 +915,7 @@
           <a:p>
             <a:fld id="{F070A7B3-6521-4DCA-87E5-044747A908C1}" type="datetimeFigureOut">
               <a:rPr lang="en-US" dirty="0"/>
-              <a:t>4/25/26</a:t>
+              <a:t>4/26/2026</a:t>
             </a:fld>
             <a:endParaRPr lang="en-US" dirty="0"/>
           </a:p>
@@ -1043,7 +1179,7 @@
           <a:p>
             <a:fld id="{1160EA64-D806-43AC-9DF2-F8C432F32B4C}" type="datetimeFigureOut">
               <a:rPr lang="en-US" dirty="0"/>
-              <a:t>4/25/26</a:t>
+              <a:t>4/26/2026</a:t>
             </a:fld>
             <a:endParaRPr lang="en-US" dirty="0"/>
           </a:p>
@@ -1271,7 +1407,7 @@
           <a:p>
             <a:fld id="{AB134690-1557-4C89-A502-4959FE7FAD70}" type="datetimeFigureOut">
               <a:rPr lang="en-US" dirty="0"/>
-              <a:t>4/25/26</a:t>
+              <a:t>4/26/2026</a:t>
             </a:fld>
             <a:endParaRPr lang="en-US" dirty="0"/>
           </a:p>
@@ -1625,7 +1761,7 @@
           <a:p>
             <a:fld id="{4F7D4976-E339-4826-83B7-FBD03F55ECF8}" type="datetimeFigureOut">
               <a:rPr lang="en-US" dirty="0"/>
-              <a:t>4/25/26</a:t>
+              <a:t>4/26/2026</a:t>
             </a:fld>
             <a:endParaRPr lang="en-US" dirty="0"/>
           </a:p>
@@ -1761,7 +1897,7 @@
           <a:p>
             <a:fld id="{E1037C31-9E7A-4F99-8774-A0E530DE1A42}" type="datetimeFigureOut">
               <a:rPr lang="en-US" dirty="0"/>
-              <a:t>4/25/26</a:t>
+              <a:t>4/26/2026</a:t>
             </a:fld>
             <a:endParaRPr lang="en-US" dirty="0"/>
           </a:p>
@@ -1851,7 +1987,7 @@
           <a:p>
             <a:fld id="{C278504F-A551-4DE0-9316-4DCD1D8CC752}" type="datetimeFigureOut">
               <a:rPr lang="en-US" dirty="0"/>
-              <a:t>4/25/26</a:t>
+              <a:t>4/26/2026</a:t>
             </a:fld>
             <a:endParaRPr lang="en-US" dirty="0"/>
           </a:p>
@@ -2203,7 +2339,7 @@
           <a:p>
             <a:fld id="{D1BE4249-C0D0-4B06-8692-E8BB871AF643}" type="datetimeFigureOut">
               <a:rPr lang="en-US" dirty="0"/>
-              <a:t>4/25/26</a:t>
+              <a:t>4/26/2026</a:t>
             </a:fld>
             <a:endParaRPr lang="en-US" dirty="0"/>
           </a:p>
@@ -2555,7 +2691,7 @@
           <a:p>
             <a:fld id="{042B0DB6-F5C7-45FB-8CF3-31B45F9C2DAC}" type="datetimeFigureOut">
               <a:rPr lang="en-US" dirty="0"/>
-              <a:t>4/25/26</a:t>
+              <a:t>4/26/2026</a:t>
             </a:fld>
             <a:endParaRPr lang="en-US" dirty="0"/>
           </a:p>
@@ -2792,7 +2928,7 @@
           <a:p>
             <a:fld id="{1160EA64-D806-43AC-9DF2-F8C432F32B4C}" type="datetimeFigureOut">
               <a:rPr lang="en-US" dirty="0"/>
-              <a:t>4/25/26</a:t>
+              <a:t>4/26/2026</a:t>
             </a:fld>
             <a:endParaRPr lang="en-US" dirty="0"/>
           </a:p>
@@ -3706,6 +3842,359 @@
     <p:bg>
       <p:bgPr>
         <a:solidFill>
+          <a:schemeClr val="bg1">
+            <a:lumMod val="95000"/>
+          </a:schemeClr>
+        </a:solidFill>
+        <a:effectLst/>
+      </p:bgPr>
+    </p:bg>
+    <p:spTree>
+      <p:nvGrpSpPr>
+        <p:cNvPr id="1" name="">
+          <a:extLst>
+            <a:ext uri="{FF2B5EF4-FFF2-40B4-BE49-F238E27FC236}">
+              <a16:creationId xmlns:a16="http://schemas.microsoft.com/office/drawing/2014/main" id="{DD9347C4-5A2F-0BEC-F9A7-CDA1955A3B78}"/>
+            </a:ext>
+          </a:extLst>
+        </p:cNvPr>
+        <p:cNvGrpSpPr/>
+        <p:nvPr/>
+      </p:nvGrpSpPr>
+      <p:grpSpPr>
+        <a:xfrm>
+          <a:off x="0" y="0"/>
+          <a:ext cx="0" cy="0"/>
+          <a:chOff x="0" y="0"/>
+          <a:chExt cx="0" cy="0"/>
+        </a:xfrm>
+      </p:grpSpPr>
+      <p:sp useBgFill="1">
+        <p:nvSpPr>
+          <p:cNvPr id="17" name="Rectangle 16">
+            <a:extLst>
+              <a:ext uri="{FF2B5EF4-FFF2-40B4-BE49-F238E27FC236}">
+                <a16:creationId xmlns:a16="http://schemas.microsoft.com/office/drawing/2014/main" id="{1660E788-AFA9-4A1B-9991-6AA74632A15B}"/>
+              </a:ext>
+              <a:ext uri="{C183D7F6-B498-43B3-948B-1728B52AA6E4}">
+                <adec:decorative xmlns:adec="http://schemas.microsoft.com/office/drawing/2017/decorative" val="1"/>
+              </a:ext>
+            </a:extLst>
+          </p:cNvPr>
+          <p:cNvSpPr>
+            <a:spLocks noGrp="1" noRot="1" noChangeAspect="1" noMove="1" noResize="1" noEditPoints="1" noAdjustHandles="1" noChangeArrowheads="1" noChangeShapeType="1" noTextEdit="1"/>
+          </p:cNvSpPr>
+          <p:nvPr>
+            <p:extLst>
+              <p:ext uri="{386F3935-93C4-4BCD-93E2-E3B085C9AB24}">
+                <p16:designElem xmlns:p16="http://schemas.microsoft.com/office/powerpoint/2015/main" val="1"/>
+              </p:ext>
+            </p:extLst>
+          </p:nvPr>
+        </p:nvSpPr>
+        <p:spPr>
+          <a:xfrm>
+            <a:off x="0" y="0"/>
+            <a:ext cx="12191999" cy="6858000"/>
+          </a:xfrm>
+          <a:prstGeom prst="rect">
+            <a:avLst/>
+          </a:prstGeom>
+          <a:ln>
+            <a:noFill/>
+          </a:ln>
+        </p:spPr>
+        <p:style>
+          <a:lnRef idx="2">
+            <a:schemeClr val="accent1">
+              <a:shade val="50000"/>
+            </a:schemeClr>
+          </a:lnRef>
+          <a:fillRef idx="1">
+            <a:schemeClr val="accent1"/>
+          </a:fillRef>
+          <a:effectRef idx="0">
+            <a:schemeClr val="accent1"/>
+          </a:effectRef>
+          <a:fontRef idx="minor">
+            <a:schemeClr val="lt1"/>
+          </a:fontRef>
+        </p:style>
+        <p:txBody>
+          <a:bodyPr rtlCol="0" anchor="ctr"/>
+          <a:lstStyle/>
+          <a:p>
+            <a:pPr algn="ctr"/>
+            <a:endParaRPr lang="en-US"/>
+          </a:p>
+        </p:txBody>
+      </p:sp>
+      <p:sp>
+        <p:nvSpPr>
+          <p:cNvPr id="19" name="Rectangle 18">
+            <a:extLst>
+              <a:ext uri="{FF2B5EF4-FFF2-40B4-BE49-F238E27FC236}">
+                <a16:creationId xmlns:a16="http://schemas.microsoft.com/office/drawing/2014/main" id="{867D4867-5BA7-4462-B2F6-A23F4A622AA7}"/>
+              </a:ext>
+              <a:ext uri="{C183D7F6-B498-43B3-948B-1728B52AA6E4}">
+                <adec:decorative xmlns:adec="http://schemas.microsoft.com/office/drawing/2017/decorative" val="1"/>
+              </a:ext>
+            </a:extLst>
+          </p:cNvPr>
+          <p:cNvSpPr>
+            <a:spLocks noGrp="1" noRot="1" noChangeAspect="1" noMove="1" noResize="1" noEditPoints="1" noAdjustHandles="1" noChangeArrowheads="1" noChangeShapeType="1" noTextEdit="1"/>
+          </p:cNvSpPr>
+          <p:nvPr>
+            <p:extLst>
+              <p:ext uri="{386F3935-93C4-4BCD-93E2-E3B085C9AB24}">
+                <p16:designElem xmlns:p16="http://schemas.microsoft.com/office/powerpoint/2015/main" val="1"/>
+              </p:ext>
+            </p:extLst>
+          </p:nvPr>
+        </p:nvSpPr>
+        <p:spPr>
+          <a:xfrm>
+            <a:off x="0" y="0"/>
+            <a:ext cx="4654296" cy="6858000"/>
+          </a:xfrm>
+          <a:prstGeom prst="rect">
+            <a:avLst/>
+          </a:prstGeom>
+          <a:solidFill>
+            <a:schemeClr val="tx2"/>
+          </a:solidFill>
+          <a:ln>
+            <a:noFill/>
+          </a:ln>
+        </p:spPr>
+        <p:style>
+          <a:lnRef idx="0">
+            <a:scrgbClr r="0" g="0" b="0"/>
+          </a:lnRef>
+          <a:fillRef idx="0">
+            <a:scrgbClr r="0" g="0" b="0"/>
+          </a:fillRef>
+          <a:effectRef idx="0">
+            <a:scrgbClr r="0" g="0" b="0"/>
+          </a:effectRef>
+          <a:fontRef idx="minor">
+            <a:schemeClr val="lt1"/>
+          </a:fontRef>
+        </p:style>
+        <p:txBody>
+          <a:bodyPr rtlCol="0" anchor="ctr"/>
+          <a:lstStyle/>
+          <a:p>
+            <a:pPr algn="ctr"/>
+            <a:endParaRPr lang="en-US"/>
+          </a:p>
+        </p:txBody>
+      </p:sp>
+      <p:sp>
+        <p:nvSpPr>
+          <p:cNvPr id="2" name="Title 1">
+            <a:extLst>
+              <a:ext uri="{FF2B5EF4-FFF2-40B4-BE49-F238E27FC236}">
+                <a16:creationId xmlns:a16="http://schemas.microsoft.com/office/drawing/2014/main" id="{4B3CA238-DF55-4DA3-B1DE-FF704AA9078B}"/>
+              </a:ext>
+            </a:extLst>
+          </p:cNvPr>
+          <p:cNvSpPr>
+            <a:spLocks noGrp="1"/>
+          </p:cNvSpPr>
+          <p:nvPr>
+            <p:ph type="title"/>
+          </p:nvPr>
+        </p:nvSpPr>
+        <p:spPr>
+          <a:xfrm>
+            <a:off x="643467" y="643467"/>
+            <a:ext cx="3363974" cy="1728044"/>
+          </a:xfrm>
+          <a:noFill/>
+          <a:ln>
+            <a:solidFill>
+              <a:schemeClr val="bg1"/>
+            </a:solidFill>
+          </a:ln>
+        </p:spPr>
+        <p:txBody>
+          <a:bodyPr wrap="square">
+            <a:normAutofit/>
+          </a:bodyPr>
+          <a:lstStyle/>
+          <a:p>
+            <a:r>
+              <a:rPr lang="en-US" dirty="0">
+                <a:solidFill>
+                  <a:schemeClr val="bg1"/>
+                </a:solidFill>
+              </a:rPr>
+              <a:t>Application Functions</a:t>
+            </a:r>
+          </a:p>
+        </p:txBody>
+      </p:sp>
+      <p:sp>
+        <p:nvSpPr>
+          <p:cNvPr id="3" name="Content Placeholder 2">
+            <a:extLst>
+              <a:ext uri="{FF2B5EF4-FFF2-40B4-BE49-F238E27FC236}">
+                <a16:creationId xmlns:a16="http://schemas.microsoft.com/office/drawing/2014/main" id="{EBA7333B-4D4C-9EFF-3C3B-48FAE12EE2A3}"/>
+              </a:ext>
+            </a:extLst>
+          </p:cNvPr>
+          <p:cNvSpPr>
+            <a:spLocks noGrp="1"/>
+          </p:cNvSpPr>
+          <p:nvPr>
+            <p:ph idx="1"/>
+          </p:nvPr>
+        </p:nvSpPr>
+        <p:spPr>
+          <a:xfrm>
+            <a:off x="643468" y="2638044"/>
+            <a:ext cx="3363974" cy="3415622"/>
+          </a:xfrm>
+        </p:spPr>
+        <p:txBody>
+          <a:bodyPr>
+            <a:normAutofit/>
+          </a:bodyPr>
+          <a:lstStyle/>
+          <a:p>
+            <a:pPr marL="0" indent="0">
+              <a:lnSpc>
+                <a:spcPct val="90000"/>
+              </a:lnSpc>
+              <a:buNone/>
+            </a:pPr>
+            <a:r>
+              <a:rPr lang="en-US" sz="1500">
+                <a:solidFill>
+                  <a:schemeClr val="bg1"/>
+                </a:solidFill>
+              </a:rPr>
+              <a:t>Our web application for the technical institute certification program has the following functions:</a:t>
+            </a:r>
+          </a:p>
+          <a:p>
+            <a:pPr>
+              <a:lnSpc>
+                <a:spcPct val="90000"/>
+              </a:lnSpc>
+            </a:pPr>
+            <a:r>
+              <a:rPr lang="en-US" sz="1500">
+                <a:solidFill>
+                  <a:schemeClr val="bg1"/>
+                </a:solidFill>
+              </a:rPr>
+              <a:t>SELECT/QUERY: Faculty can look up student, course, and certification data.</a:t>
+            </a:r>
+          </a:p>
+          <a:p>
+            <a:pPr>
+              <a:lnSpc>
+                <a:spcPct val="90000"/>
+              </a:lnSpc>
+            </a:pPr>
+            <a:r>
+              <a:rPr lang="en-US" sz="1500">
+                <a:solidFill>
+                  <a:schemeClr val="bg1"/>
+                </a:solidFill>
+              </a:rPr>
+              <a:t>INSERT: Faculty can add new students, courses, or certifications.</a:t>
+            </a:r>
+          </a:p>
+          <a:p>
+            <a:pPr>
+              <a:lnSpc>
+                <a:spcPct val="90000"/>
+              </a:lnSpc>
+            </a:pPr>
+            <a:r>
+              <a:rPr lang="en-US" sz="1500">
+                <a:solidFill>
+                  <a:schemeClr val="bg1"/>
+                </a:solidFill>
+              </a:rPr>
+              <a:t>UPDATE: Faculty can update student, course, and certification information.</a:t>
+            </a:r>
+          </a:p>
+          <a:p>
+            <a:pPr>
+              <a:lnSpc>
+                <a:spcPct val="90000"/>
+              </a:lnSpc>
+            </a:pPr>
+            <a:r>
+              <a:rPr lang="en-US" sz="1500">
+                <a:solidFill>
+                  <a:schemeClr val="bg1"/>
+                </a:solidFill>
+              </a:rPr>
+              <a:t>DELETE: Faculty can remove students, courses, or certifications as needed.</a:t>
+            </a:r>
+          </a:p>
+        </p:txBody>
+      </p:sp>
+      <p:pic>
+        <p:nvPicPr>
+          <p:cNvPr id="5" name="Graphic 4" descr="Laptop with phone and calculator">
+            <a:extLst>
+              <a:ext uri="{FF2B5EF4-FFF2-40B4-BE49-F238E27FC236}">
+                <a16:creationId xmlns:a16="http://schemas.microsoft.com/office/drawing/2014/main" id="{839CD98F-A31F-E243-FA84-1F33A652D132}"/>
+              </a:ext>
+            </a:extLst>
+          </p:cNvPr>
+          <p:cNvPicPr>
+            <a:picLocks noChangeAspect="1"/>
+          </p:cNvPicPr>
+          <p:nvPr/>
+        </p:nvPicPr>
+        <p:blipFill>
+          <a:blip>
+            <a:extLst>
+              <a:ext uri="{96DAC541-7B7A-43D3-8B79-37D633B846F1}">
+                <asvg:svgBlip xmlns:asvg="http://schemas.microsoft.com/office/drawing/2016/SVG/main" r:embed="rId2"/>
+              </a:ext>
+            </a:extLst>
+          </a:blip>
+          <a:stretch>
+            <a:fillRect/>
+          </a:stretch>
+        </p:blipFill>
+        <p:spPr>
+          <a:xfrm>
+            <a:off x="5718048" y="643467"/>
+            <a:ext cx="5410199" cy="5410199"/>
+          </a:xfrm>
+          <a:prstGeom prst="rect">
+            <a:avLst/>
+          </a:prstGeom>
+        </p:spPr>
+      </p:pic>
+    </p:spTree>
+    <p:extLst>
+      <p:ext uri="{BB962C8B-B14F-4D97-AF65-F5344CB8AC3E}">
+        <p14:creationId xmlns:p14="http://schemas.microsoft.com/office/powerpoint/2010/main" val="3285580046"/>
+      </p:ext>
+    </p:extLst>
+  </p:cSld>
+  <p:clrMapOvr>
+    <a:masterClrMapping/>
+  </p:clrMapOvr>
+</p:sld>
+</file>
+
+<file path=ppt/slides/slide5.xml><?xml version="1.0" encoding="utf-8"?>
+<p:sld xmlns:a="http://schemas.openxmlformats.org/drawingml/2006/main" xmlns:r="http://schemas.openxmlformats.org/officeDocument/2006/relationships" xmlns:p="http://schemas.openxmlformats.org/presentationml/2006/main">
+  <p:cSld>
+    <p:bg>
+      <p:bgPr>
+        <a:solidFill>
           <a:schemeClr val="accent2"/>
         </a:solidFill>
         <a:effectLst/>

</xml_diff>